<commit_message>
docs & feat: update final deliverables, technical report, presentation video, and README
</commit_message>
<xml_diff>
--- a/Projeto_Final_Artefatos/InsurMinds_Projeto_Final.pptx
+++ b/Projeto_Final_Artefatos/InsurMinds_Projeto_Final.pptx
@@ -5,15 +5,15 @@
     <p:sldMasterId id="2147483648" r:id="rId1"/>
   </p:sldMasterIdLst>
   <p:sldIdLst>
-    <p:sldId id="256" r:id="rId7"/>
-    <p:sldId id="257" r:id="rId8"/>
-    <p:sldId id="258" r:id="rId9"/>
-    <p:sldId id="259" r:id="rId10"/>
-    <p:sldId id="260" r:id="rId11"/>
-    <p:sldId id="261" r:id="rId12"/>
-    <p:sldId id="262" r:id="rId13"/>
+    <p:sldId id="256" r:id="rId2"/>
+    <p:sldId id="257" r:id="rId3"/>
+    <p:sldId id="258" r:id="rId4"/>
+    <p:sldId id="259" r:id="rId5"/>
+    <p:sldId id="260" r:id="rId6"/>
+    <p:sldId id="261" r:id="rId7"/>
+    <p:sldId id="262" r:id="rId8"/>
   </p:sldIdLst>
-  <p:sldSz cx="12191695" cy="6858000" type="screen4x3"/>
+  <p:sldSz cx="12192000" cy="6858000"/>
   <p:notesSz cx="6858000" cy="9144000"/>
   <p:defaultTextStyle>
     <a:defPPr>
@@ -110,6 +110,22 @@
       </a:defRPr>
     </a:lvl9pPr>
   </p:defaultTextStyle>
+  <p:extLst>
+    <p:ext uri="{EFAFB233-063F-42B5-8137-9DF3F51BA10A}">
+      <p15:sldGuideLst xmlns:p15="http://schemas.microsoft.com/office/powerpoint/2012/main">
+        <p15:guide id="1" orient="horz" pos="2160">
+          <p15:clr>
+            <a:srgbClr val="A4A3A4"/>
+          </p15:clr>
+        </p15:guide>
+        <p15:guide id="2" pos="2880">
+          <p15:clr>
+            <a:srgbClr val="A4A3A4"/>
+          </p15:clr>
+        </p15:guide>
+      </p15:sldGuideLst>
+    </p:ext>
+  </p:extLst>
 </p:presentation>
 </file>
 
@@ -294,7 +310,7 @@
           <a:p>
             <a:fld id="{5BCAD085-E8A6-8845-BD4E-CB4CCA059FC4}" type="datetimeFigureOut">
               <a:rPr lang="en-US" smtClean="0"/>
-              <a:t>1/27/13</a:t>
+              <a:t>10/6/2026</a:t>
             </a:fld>
             <a:endParaRPr lang="en-US"/>
           </a:p>
@@ -336,7 +352,7 @@
           <a:p>
             <a:fld id="{C1FF6DA9-008F-8B48-92A6-B652298478BF}" type="slidenum">
               <a:rPr lang="en-US" smtClean="0"/>
-              <a:t>‹#›</a:t>
+              <a:t>‹nº›</a:t>
             </a:fld>
             <a:endParaRPr lang="en-US"/>
           </a:p>
@@ -464,7 +480,7 @@
           <a:p>
             <a:fld id="{5BCAD085-E8A6-8845-BD4E-CB4CCA059FC4}" type="datetimeFigureOut">
               <a:rPr lang="en-US" smtClean="0"/>
-              <a:t>1/27/13</a:t>
+              <a:t>10/6/2026</a:t>
             </a:fld>
             <a:endParaRPr lang="en-US"/>
           </a:p>
@@ -506,7 +522,7 @@
           <a:p>
             <a:fld id="{C1FF6DA9-008F-8B48-92A6-B652298478BF}" type="slidenum">
               <a:rPr lang="en-US" smtClean="0"/>
-              <a:t>‹#›</a:t>
+              <a:t>‹nº›</a:t>
             </a:fld>
             <a:endParaRPr lang="en-US"/>
           </a:p>
@@ -644,7 +660,7 @@
           <a:p>
             <a:fld id="{5BCAD085-E8A6-8845-BD4E-CB4CCA059FC4}" type="datetimeFigureOut">
               <a:rPr lang="en-US" smtClean="0"/>
-              <a:t>1/27/13</a:t>
+              <a:t>10/6/2026</a:t>
             </a:fld>
             <a:endParaRPr lang="en-US"/>
           </a:p>
@@ -686,7 +702,7 @@
           <a:p>
             <a:fld id="{C1FF6DA9-008F-8B48-92A6-B652298478BF}" type="slidenum">
               <a:rPr lang="en-US" smtClean="0"/>
-              <a:t>‹#›</a:t>
+              <a:t>‹nº›</a:t>
             </a:fld>
             <a:endParaRPr lang="en-US"/>
           </a:p>
@@ -814,7 +830,7 @@
           <a:p>
             <a:fld id="{5BCAD085-E8A6-8845-BD4E-CB4CCA059FC4}" type="datetimeFigureOut">
               <a:rPr lang="en-US" smtClean="0"/>
-              <a:t>1/27/13</a:t>
+              <a:t>10/6/2026</a:t>
             </a:fld>
             <a:endParaRPr lang="en-US"/>
           </a:p>
@@ -856,7 +872,7 @@
           <a:p>
             <a:fld id="{C1FF6DA9-008F-8B48-92A6-B652298478BF}" type="slidenum">
               <a:rPr lang="en-US" smtClean="0"/>
-              <a:t>‹#›</a:t>
+              <a:t>‹nº›</a:t>
             </a:fld>
             <a:endParaRPr lang="en-US"/>
           </a:p>
@@ -1060,7 +1076,7 @@
           <a:p>
             <a:fld id="{5BCAD085-E8A6-8845-BD4E-CB4CCA059FC4}" type="datetimeFigureOut">
               <a:rPr lang="en-US" smtClean="0"/>
-              <a:t>1/27/13</a:t>
+              <a:t>10/6/2026</a:t>
             </a:fld>
             <a:endParaRPr lang="en-US"/>
           </a:p>
@@ -1102,7 +1118,7 @@
           <a:p>
             <a:fld id="{C1FF6DA9-008F-8B48-92A6-B652298478BF}" type="slidenum">
               <a:rPr lang="en-US" smtClean="0"/>
-              <a:t>‹#›</a:t>
+              <a:t>‹nº›</a:t>
             </a:fld>
             <a:endParaRPr lang="en-US"/>
           </a:p>
@@ -1348,7 +1364,7 @@
           <a:p>
             <a:fld id="{5BCAD085-E8A6-8845-BD4E-CB4CCA059FC4}" type="datetimeFigureOut">
               <a:rPr lang="en-US" smtClean="0"/>
-              <a:t>1/27/13</a:t>
+              <a:t>10/6/2026</a:t>
             </a:fld>
             <a:endParaRPr lang="en-US"/>
           </a:p>
@@ -1390,7 +1406,7 @@
           <a:p>
             <a:fld id="{C1FF6DA9-008F-8B48-92A6-B652298478BF}" type="slidenum">
               <a:rPr lang="en-US" smtClean="0"/>
-              <a:t>‹#›</a:t>
+              <a:t>‹nº›</a:t>
             </a:fld>
             <a:endParaRPr lang="en-US"/>
           </a:p>
@@ -1770,7 +1786,7 @@
           <a:p>
             <a:fld id="{5BCAD085-E8A6-8845-BD4E-CB4CCA059FC4}" type="datetimeFigureOut">
               <a:rPr lang="en-US" smtClean="0"/>
-              <a:t>1/27/13</a:t>
+              <a:t>10/6/2026</a:t>
             </a:fld>
             <a:endParaRPr lang="en-US"/>
           </a:p>
@@ -1812,7 +1828,7 @@
           <a:p>
             <a:fld id="{C1FF6DA9-008F-8B48-92A6-B652298478BF}" type="slidenum">
               <a:rPr lang="en-US" smtClean="0"/>
-              <a:t>‹#›</a:t>
+              <a:t>‹nº›</a:t>
             </a:fld>
             <a:endParaRPr lang="en-US"/>
           </a:p>
@@ -1888,7 +1904,7 @@
           <a:p>
             <a:fld id="{5BCAD085-E8A6-8845-BD4E-CB4CCA059FC4}" type="datetimeFigureOut">
               <a:rPr lang="en-US" smtClean="0"/>
-              <a:t>1/27/13</a:t>
+              <a:t>10/6/2026</a:t>
             </a:fld>
             <a:endParaRPr lang="en-US"/>
           </a:p>
@@ -1930,7 +1946,7 @@
           <a:p>
             <a:fld id="{C1FF6DA9-008F-8B48-92A6-B652298478BF}" type="slidenum">
               <a:rPr lang="en-US" smtClean="0"/>
-              <a:t>‹#›</a:t>
+              <a:t>‹nº›</a:t>
             </a:fld>
             <a:endParaRPr lang="en-US"/>
           </a:p>
@@ -1983,7 +1999,7 @@
           <a:p>
             <a:fld id="{5BCAD085-E8A6-8845-BD4E-CB4CCA059FC4}" type="datetimeFigureOut">
               <a:rPr lang="en-US" smtClean="0"/>
-              <a:t>1/27/13</a:t>
+              <a:t>10/6/2026</a:t>
             </a:fld>
             <a:endParaRPr lang="en-US"/>
           </a:p>
@@ -2025,7 +2041,7 @@
           <a:p>
             <a:fld id="{C1FF6DA9-008F-8B48-92A6-B652298478BF}" type="slidenum">
               <a:rPr lang="en-US" smtClean="0"/>
-              <a:t>‹#›</a:t>
+              <a:t>‹nº›</a:t>
             </a:fld>
             <a:endParaRPr lang="en-US"/>
           </a:p>
@@ -2260,7 +2276,7 @@
           <a:p>
             <a:fld id="{5BCAD085-E8A6-8845-BD4E-CB4CCA059FC4}" type="datetimeFigureOut">
               <a:rPr lang="en-US" smtClean="0"/>
-              <a:t>1/27/13</a:t>
+              <a:t>10/6/2026</a:t>
             </a:fld>
             <a:endParaRPr lang="en-US"/>
           </a:p>
@@ -2302,7 +2318,7 @@
           <a:p>
             <a:fld id="{C1FF6DA9-008F-8B48-92A6-B652298478BF}" type="slidenum">
               <a:rPr lang="en-US" smtClean="0"/>
-              <a:t>‹#›</a:t>
+              <a:t>‹nº›</a:t>
             </a:fld>
             <a:endParaRPr lang="en-US"/>
           </a:p>
@@ -2513,7 +2529,7 @@
           <a:p>
             <a:fld id="{5BCAD085-E8A6-8845-BD4E-CB4CCA059FC4}" type="datetimeFigureOut">
               <a:rPr lang="en-US" smtClean="0"/>
-              <a:t>1/27/13</a:t>
+              <a:t>10/6/2026</a:t>
             </a:fld>
             <a:endParaRPr lang="en-US"/>
           </a:p>
@@ -2555,7 +2571,7 @@
           <a:p>
             <a:fld id="{C1FF6DA9-008F-8B48-92A6-B652298478BF}" type="slidenum">
               <a:rPr lang="en-US" smtClean="0"/>
-              <a:t>‹#›</a:t>
+              <a:t>‹nº›</a:t>
             </a:fld>
             <a:endParaRPr lang="en-US"/>
           </a:p>
@@ -2726,7 +2742,7 @@
           <a:p>
             <a:fld id="{5BCAD085-E8A6-8845-BD4E-CB4CCA059FC4}" type="datetimeFigureOut">
               <a:rPr lang="en-US" smtClean="0"/>
-              <a:t>1/27/13</a:t>
+              <a:t>10/6/2026</a:t>
             </a:fld>
             <a:endParaRPr lang="en-US"/>
           </a:p>
@@ -2804,7 +2820,7 @@
           <a:p>
             <a:fld id="{C1FF6DA9-008F-8B48-92A6-B652298478BF}" type="slidenum">
               <a:rPr lang="en-US" smtClean="0"/>
-              <a:t>‹#›</a:t>
+              <a:t>‹nº›</a:t>
             </a:fld>
             <a:endParaRPr lang="en-US"/>
           </a:p>
@@ -3085,7 +3101,7 @@
 </file>
 
 <file path=ppt/slides/slide1.xml><?xml version="1.0" encoding="utf-8"?>
-<p:sld xmlns:a="http://schemas.openxmlformats.org/drawingml/2006/main" xmlns:p="http://schemas.openxmlformats.org/presentationml/2006/main" xmlns:r="http://schemas.openxmlformats.org/officeDocument/2006/relationships">
+<p:sld xmlns:a="http://schemas.openxmlformats.org/drawingml/2006/main" xmlns:r="http://schemas.openxmlformats.org/officeDocument/2006/relationships" xmlns:p="http://schemas.openxmlformats.org/presentationml/2006/main">
   <p:cSld>
     <p:bg>
       <p:bgPr>
@@ -3101,7 +3117,14 @@
         <p:cNvGrpSpPr/>
         <p:nvPr/>
       </p:nvGrpSpPr>
-      <p:grpSpPr/>
+      <p:grpSpPr>
+        <a:xfrm>
+          <a:off x="0" y="0"/>
+          <a:ext cx="0" cy="0"/>
+          <a:chOff x="0" y="0"/>
+          <a:chExt cx="0" cy="0"/>
+        </a:xfrm>
+      </p:grpSpPr>
       <p:sp>
         <p:nvSpPr>
           <p:cNvPr id="2" name="TextBox 1"/>
@@ -3191,7 +3214,7 @@
 </file>
 
 <file path=ppt/slides/slide2.xml><?xml version="1.0" encoding="utf-8"?>
-<p:sld xmlns:a="http://schemas.openxmlformats.org/drawingml/2006/main" xmlns:p="http://schemas.openxmlformats.org/presentationml/2006/main" xmlns:r="http://schemas.openxmlformats.org/officeDocument/2006/relationships">
+<p:sld xmlns:a="http://schemas.openxmlformats.org/drawingml/2006/main" xmlns:r="http://schemas.openxmlformats.org/officeDocument/2006/relationships" xmlns:p="http://schemas.openxmlformats.org/presentationml/2006/main">
   <p:cSld>
     <p:bg>
       <p:bgPr>
@@ -3207,7 +3230,14 @@
         <p:cNvGrpSpPr/>
         <p:nvPr/>
       </p:nvGrpSpPr>
-      <p:grpSpPr/>
+      <p:grpSpPr>
+        <a:xfrm>
+          <a:off x="0" y="0"/>
+          <a:ext cx="0" cy="0"/>
+          <a:chOff x="0" y="0"/>
+          <a:chExt cx="0" cy="0"/>
+        </a:xfrm>
+      </p:grpSpPr>
       <p:sp>
         <p:nvSpPr>
           <p:cNvPr id="2" name="TextBox 1"/>
@@ -3320,6 +3350,7 @@
           <a:lstStyle/>
           <a:p>
             <a:pPr algn="ctr"/>
+            <a:endParaRPr/>
           </a:p>
         </p:txBody>
       </p:sp>
@@ -3415,6 +3446,7 @@
           <a:lstStyle/>
           <a:p>
             <a:pPr algn="ctr"/>
+            <a:endParaRPr/>
           </a:p>
         </p:txBody>
       </p:sp>
@@ -3510,6 +3542,7 @@
           <a:lstStyle/>
           <a:p>
             <a:pPr algn="ctr"/>
+            <a:endParaRPr/>
           </a:p>
         </p:txBody>
       </p:sp>
@@ -3572,7 +3605,7 @@
 </file>
 
 <file path=ppt/slides/slide3.xml><?xml version="1.0" encoding="utf-8"?>
-<p:sld xmlns:a="http://schemas.openxmlformats.org/drawingml/2006/main" xmlns:p="http://schemas.openxmlformats.org/presentationml/2006/main" xmlns:r="http://schemas.openxmlformats.org/officeDocument/2006/relationships">
+<p:sld xmlns:a="http://schemas.openxmlformats.org/drawingml/2006/main" xmlns:r="http://schemas.openxmlformats.org/officeDocument/2006/relationships" xmlns:p="http://schemas.openxmlformats.org/presentationml/2006/main">
   <p:cSld>
     <p:bg>
       <p:bgPr>
@@ -3588,7 +3621,14 @@
         <p:cNvGrpSpPr/>
         <p:nvPr/>
       </p:nvGrpSpPr>
-      <p:grpSpPr/>
+      <p:grpSpPr>
+        <a:xfrm>
+          <a:off x="0" y="0"/>
+          <a:ext cx="0" cy="0"/>
+          <a:chOff x="0" y="0"/>
+          <a:chExt cx="0" cy="0"/>
+        </a:xfrm>
+      </p:grpSpPr>
       <p:sp>
         <p:nvSpPr>
           <p:cNvPr id="2" name="TextBox 1"/>
@@ -3701,6 +3741,7 @@
           <a:lstStyle/>
           <a:p>
             <a:pPr algn="ctr"/>
+            <a:endParaRPr/>
           </a:p>
         </p:txBody>
       </p:sp>
@@ -3826,7 +3867,7 @@
 </file>
 
 <file path=ppt/slides/slide4.xml><?xml version="1.0" encoding="utf-8"?>
-<p:sld xmlns:a="http://schemas.openxmlformats.org/drawingml/2006/main" xmlns:p="http://schemas.openxmlformats.org/presentationml/2006/main" xmlns:r="http://schemas.openxmlformats.org/officeDocument/2006/relationships">
+<p:sld xmlns:a="http://schemas.openxmlformats.org/drawingml/2006/main" xmlns:r="http://schemas.openxmlformats.org/officeDocument/2006/relationships" xmlns:p="http://schemas.openxmlformats.org/presentationml/2006/main">
   <p:cSld>
     <p:bg>
       <p:bgPr>
@@ -3842,7 +3883,14 @@
         <p:cNvGrpSpPr/>
         <p:nvPr/>
       </p:nvGrpSpPr>
-      <p:grpSpPr/>
+      <p:grpSpPr>
+        <a:xfrm>
+          <a:off x="0" y="0"/>
+          <a:ext cx="0" cy="0"/>
+          <a:chOff x="0" y="0"/>
+          <a:chExt cx="0" cy="0"/>
+        </a:xfrm>
+      </p:grpSpPr>
       <p:sp>
         <p:nvSpPr>
           <p:cNvPr id="2" name="TextBox 1"/>
@@ -3955,6 +4003,7 @@
           <a:lstStyle/>
           <a:p>
             <a:pPr algn="ctr"/>
+            <a:endParaRPr/>
           </a:p>
         </p:txBody>
       </p:sp>
@@ -4043,6 +4092,7 @@
           <a:lstStyle/>
           <a:p>
             <a:pPr algn="ctr"/>
+            <a:endParaRPr/>
           </a:p>
         </p:txBody>
       </p:sp>
@@ -4131,6 +4181,7 @@
           <a:lstStyle/>
           <a:p>
             <a:pPr algn="ctr"/>
+            <a:endParaRPr/>
           </a:p>
         </p:txBody>
       </p:sp>
@@ -4219,6 +4270,7 @@
           <a:lstStyle/>
           <a:p>
             <a:pPr algn="ctr"/>
+            <a:endParaRPr/>
           </a:p>
         </p:txBody>
       </p:sp>
@@ -4307,6 +4359,7 @@
           <a:lstStyle/>
           <a:p>
             <a:pPr algn="ctr"/>
+            <a:endParaRPr/>
           </a:p>
         </p:txBody>
       </p:sp>
@@ -4362,7 +4415,7 @@
 </file>
 
 <file path=ppt/slides/slide5.xml><?xml version="1.0" encoding="utf-8"?>
-<p:sld xmlns:a="http://schemas.openxmlformats.org/drawingml/2006/main" xmlns:p="http://schemas.openxmlformats.org/presentationml/2006/main" xmlns:r="http://schemas.openxmlformats.org/officeDocument/2006/relationships">
+<p:sld xmlns:a="http://schemas.openxmlformats.org/drawingml/2006/main" xmlns:r="http://schemas.openxmlformats.org/officeDocument/2006/relationships" xmlns:p="http://schemas.openxmlformats.org/presentationml/2006/main">
   <p:cSld>
     <p:bg>
       <p:bgPr>
@@ -4378,7 +4431,14 @@
         <p:cNvGrpSpPr/>
         <p:nvPr/>
       </p:nvGrpSpPr>
-      <p:grpSpPr/>
+      <p:grpSpPr>
+        <a:xfrm>
+          <a:off x="0" y="0"/>
+          <a:ext cx="0" cy="0"/>
+          <a:chOff x="0" y="0"/>
+          <a:chExt cx="0" cy="0"/>
+        </a:xfrm>
+      </p:grpSpPr>
       <p:sp>
         <p:nvSpPr>
           <p:cNvPr id="2" name="TextBox 1"/>
@@ -4491,6 +4551,7 @@
           <a:lstStyle/>
           <a:p>
             <a:pPr algn="ctr"/>
+            <a:endParaRPr/>
           </a:p>
         </p:txBody>
       </p:sp>
@@ -4649,6 +4710,7 @@
           <a:lstStyle/>
           <a:p>
             <a:pPr algn="ctr"/>
+            <a:endParaRPr/>
           </a:p>
         </p:txBody>
       </p:sp>
@@ -4807,6 +4869,7 @@
           <a:lstStyle/>
           <a:p>
             <a:pPr algn="ctr"/>
+            <a:endParaRPr/>
           </a:p>
         </p:txBody>
       </p:sp>
@@ -4932,7 +4995,7 @@
 </file>
 
 <file path=ppt/slides/slide6.xml><?xml version="1.0" encoding="utf-8"?>
-<p:sld xmlns:a="http://schemas.openxmlformats.org/drawingml/2006/main" xmlns:p="http://schemas.openxmlformats.org/presentationml/2006/main" xmlns:r="http://schemas.openxmlformats.org/officeDocument/2006/relationships">
+<p:sld xmlns:a="http://schemas.openxmlformats.org/drawingml/2006/main" xmlns:r="http://schemas.openxmlformats.org/officeDocument/2006/relationships" xmlns:p="http://schemas.openxmlformats.org/presentationml/2006/main">
   <p:cSld>
     <p:bg>
       <p:bgPr>
@@ -4948,7 +5011,14 @@
         <p:cNvGrpSpPr/>
         <p:nvPr/>
       </p:nvGrpSpPr>
-      <p:grpSpPr/>
+      <p:grpSpPr>
+        <a:xfrm>
+          <a:off x="0" y="0"/>
+          <a:ext cx="0" cy="0"/>
+          <a:chOff x="0" y="0"/>
+          <a:chExt cx="0" cy="0"/>
+        </a:xfrm>
+      </p:grpSpPr>
       <p:sp>
         <p:nvSpPr>
           <p:cNvPr id="2" name="TextBox 1"/>
@@ -5061,6 +5131,7 @@
           <a:lstStyle/>
           <a:p>
             <a:pPr algn="ctr"/>
+            <a:endParaRPr/>
           </a:p>
         </p:txBody>
       </p:sp>
@@ -5186,7 +5257,7 @@
 </file>
 
 <file path=ppt/slides/slide7.xml><?xml version="1.0" encoding="utf-8"?>
-<p:sld xmlns:a="http://schemas.openxmlformats.org/drawingml/2006/main" xmlns:p="http://schemas.openxmlformats.org/presentationml/2006/main" xmlns:r="http://schemas.openxmlformats.org/officeDocument/2006/relationships">
+<p:sld xmlns:a="http://schemas.openxmlformats.org/drawingml/2006/main" xmlns:r="http://schemas.openxmlformats.org/officeDocument/2006/relationships" xmlns:p="http://schemas.openxmlformats.org/presentationml/2006/main">
   <p:cSld>
     <p:bg>
       <p:bgPr>
@@ -5202,7 +5273,14 @@
         <p:cNvGrpSpPr/>
         <p:nvPr/>
       </p:nvGrpSpPr>
-      <p:grpSpPr/>
+      <p:grpSpPr>
+        <a:xfrm>
+          <a:off x="0" y="0"/>
+          <a:ext cx="0" cy="0"/>
+          <a:chOff x="0" y="0"/>
+          <a:chExt cx="0" cy="0"/>
+        </a:xfrm>
+      </p:grpSpPr>
       <p:sp>
         <p:nvSpPr>
           <p:cNvPr id="2" name="TextBox 1"/>
@@ -5212,7 +5290,7 @@
         <p:spPr>
           <a:xfrm>
             <a:off x="914400" y="1828800"/>
-            <a:ext cx="10332720" cy="3200400"/>
+            <a:ext cx="10332720" cy="3231654"/>
           </a:xfrm>
           <a:prstGeom prst="rect">
             <a:avLst/>
@@ -5236,7 +5314,20 @@
               </a:defRPr>
             </a:pPr>
             <a:r>
-              <a:t>InsurMinds Apólice 360</a:t>
+              <a:rPr dirty="0" err="1"/>
+              <a:t>InsurMinds</a:t>
+            </a:r>
+            <a:r>
+              <a:rPr dirty="0"/>
+              <a:t> </a:t>
+            </a:r>
+            <a:r>
+              <a:rPr dirty="0" err="1"/>
+              <a:t>Apólice</a:t>
+            </a:r>
+            <a:r>
+              <a:rPr dirty="0"/>
+              <a:t> 360</a:t>
             </a:r>
           </a:p>
           <a:p>
@@ -5251,7 +5342,80 @@
               </a:defRPr>
             </a:pPr>
             <a:r>
-              <a:t>A IA Generativa transformando a inteligência e a segurança jurídica nas decisões de gestão corporativa.</a:t>
+              <a:rPr dirty="0"/>
+              <a:t>A IA </a:t>
+            </a:r>
+            <a:r>
+              <a:rPr dirty="0" err="1"/>
+              <a:t>Generativa</a:t>
+            </a:r>
+            <a:r>
+              <a:rPr dirty="0"/>
+              <a:t> </a:t>
+            </a:r>
+            <a:r>
+              <a:rPr dirty="0" err="1"/>
+              <a:t>transformando</a:t>
+            </a:r>
+            <a:r>
+              <a:rPr dirty="0"/>
+              <a:t> a </a:t>
+            </a:r>
+            <a:r>
+              <a:rPr dirty="0" err="1"/>
+              <a:t>inteligência</a:t>
+            </a:r>
+            <a:r>
+              <a:rPr dirty="0"/>
+              <a:t> e a </a:t>
+            </a:r>
+            <a:r>
+              <a:rPr dirty="0" err="1"/>
+              <a:t>segurança</a:t>
+            </a:r>
+            <a:r>
+              <a:rPr dirty="0"/>
+              <a:t> </a:t>
+            </a:r>
+            <a:r>
+              <a:rPr dirty="0" err="1"/>
+              <a:t>jurídica</a:t>
+            </a:r>
+            <a:r>
+              <a:rPr dirty="0"/>
+              <a:t> </a:t>
+            </a:r>
+            <a:r>
+              <a:rPr dirty="0" err="1"/>
+              <a:t>nas</a:t>
+            </a:r>
+            <a:r>
+              <a:rPr dirty="0"/>
+              <a:t> </a:t>
+            </a:r>
+            <a:r>
+              <a:rPr dirty="0" err="1"/>
+              <a:t>decisões</a:t>
+            </a:r>
+            <a:r>
+              <a:rPr dirty="0"/>
+              <a:t> de </a:t>
+            </a:r>
+            <a:r>
+              <a:rPr dirty="0" err="1"/>
+              <a:t>gestão</a:t>
+            </a:r>
+            <a:r>
+              <a:rPr dirty="0"/>
+              <a:t> </a:t>
+            </a:r>
+            <a:r>
+              <a:rPr dirty="0" err="1"/>
+              <a:t>corporativa</a:t>
+            </a:r>
+            <a:r>
+              <a:rPr dirty="0"/>
+              <a:t>.</a:t>
             </a:r>
           </a:p>
           <a:p>
@@ -5263,8 +5427,136 @@
               </a:defRPr>
             </a:pPr>
             <a:r>
-              <a:t>Obrigado! • Projeto Final do Instituto de Inteligência Artificial Aplicada (I2A2)</a:t>
-            </a:r>
+              <a:rPr dirty="0"/>
+              <a:t>Obrigado! • </a:t>
+            </a:r>
+            <a:r>
+              <a:rPr dirty="0" err="1"/>
+              <a:t>Projeto</a:t>
+            </a:r>
+            <a:r>
+              <a:rPr dirty="0"/>
+              <a:t> Final do </a:t>
+            </a:r>
+            <a:r>
+              <a:rPr dirty="0" err="1"/>
+              <a:t>Instituto</a:t>
+            </a:r>
+            <a:r>
+              <a:rPr dirty="0"/>
+              <a:t> de </a:t>
+            </a:r>
+            <a:r>
+              <a:rPr dirty="0" err="1"/>
+              <a:t>Inteligência</a:t>
+            </a:r>
+            <a:r>
+              <a:rPr dirty="0"/>
+              <a:t> Artificial </a:t>
+            </a:r>
+            <a:r>
+              <a:rPr dirty="0" err="1"/>
+              <a:t>Aplicada</a:t>
+            </a:r>
+            <a:r>
+              <a:rPr dirty="0"/>
+              <a:t> (I2A2</a:t>
+            </a:r>
+            <a:r>
+              <a:rPr dirty="0" smtClean="0"/>
+              <a:t>)</a:t>
+            </a:r>
+            <a:endParaRPr lang="pt-BR" dirty="0" smtClean="0"/>
+          </a:p>
+          <a:p>
+            <a:pPr>
+              <a:defRPr sz="1400">
+                <a:solidFill>
+                  <a:srgbClr val="94A3B8"/>
+                </a:solidFill>
+              </a:defRPr>
+            </a:pPr>
+            <a:endParaRPr lang="pt-BR" dirty="0" smtClean="0"/>
+          </a:p>
+          <a:p>
+            <a:pPr>
+              <a:defRPr sz="1400">
+                <a:solidFill>
+                  <a:srgbClr val="94A3B8"/>
+                </a:solidFill>
+              </a:defRPr>
+            </a:pPr>
+            <a:endParaRPr lang="pt-BR" dirty="0" smtClean="0"/>
+          </a:p>
+          <a:p>
+            <a:pPr>
+              <a:defRPr sz="1400">
+                <a:solidFill>
+                  <a:srgbClr val="94A3B8"/>
+                </a:solidFill>
+              </a:defRPr>
+            </a:pPr>
+            <a:endParaRPr lang="pt-BR" dirty="0"/>
+          </a:p>
+          <a:p>
+            <a:pPr algn="ctr">
+              <a:defRPr sz="1400">
+                <a:solidFill>
+                  <a:srgbClr val="94A3B8"/>
+                </a:solidFill>
+              </a:defRPr>
+            </a:pPr>
+            <a:r>
+              <a:rPr lang="pt-BR" sz="2000" b="1" dirty="0" smtClean="0">
+                <a:effectLst>
+                  <a:outerShdw blurRad="38100" dist="38100" dir="2700000" algn="tl">
+                    <a:srgbClr val="000000">
+                      <a:alpha val="43137"/>
+                    </a:srgbClr>
+                  </a:outerShdw>
+                </a:effectLst>
+              </a:rPr>
+              <a:t>Diogo David Macêdo Sena</a:t>
+            </a:r>
+          </a:p>
+          <a:p>
+            <a:pPr algn="ctr">
+              <a:defRPr sz="1400">
+                <a:solidFill>
+                  <a:srgbClr val="94A3B8"/>
+                </a:solidFill>
+              </a:defRPr>
+            </a:pPr>
+            <a:r>
+              <a:rPr lang="pt-BR" sz="2000" b="1" dirty="0">
+                <a:effectLst>
+                  <a:outerShdw blurRad="38100" dist="38100" dir="2700000" algn="tl">
+                    <a:srgbClr val="000000">
+                      <a:alpha val="43137"/>
+                    </a:srgbClr>
+                  </a:outerShdw>
+                </a:effectLst>
+              </a:rPr>
+              <a:t>Líder Técnico</a:t>
+            </a:r>
+          </a:p>
+          <a:p>
+            <a:pPr>
+              <a:defRPr sz="1400">
+                <a:solidFill>
+                  <a:srgbClr val="94A3B8"/>
+                </a:solidFill>
+              </a:defRPr>
+            </a:pPr>
+            <a:endParaRPr sz="2000" b="1" dirty="0">
+              <a:effectLst>
+                <a:outerShdw blurRad="38100" dist="38100" dir="2700000" algn="tl">
+                  <a:srgbClr val="000000">
+                    <a:alpha val="43137"/>
+                  </a:srgbClr>
+                </a:outerShdw>
+              </a:effectLst>
+            </a:endParaRPr>
           </a:p>
         </p:txBody>
       </p:sp>

</xml_diff>